<commit_message>
Make ATMOS A0 PowerPoint connectors glued to box connection points (reflow on move)
Co-Authored-By: Claude Opus 4.8 <noreply@anthropic.com>
Claude-Session: https://claude.ai/code/session_01F8o6wfF4vD658yfPcrhtEZ
</commit_message>
<xml_diff>
--- a/ATMOS_A0_native.pptx
+++ b/ATMOS_A0_native.pptx
@@ -7,7 +7,7 @@
   <p:sldIdLst>
     <p:sldId id="256" r:id="rId7"/>
   </p:sldIdLst>
-  <p:sldSz cx="20116800" cy="10515600" type="screen4x3"/>
+  <p:sldSz cx="21031200" cy="10058400" type="screen4x3"/>
   <p:notesSz cx="6858000" cy="9144000"/>
   <p:defaultTextStyle>
     <a:defPPr>
@@ -3097,7 +3097,7 @@
         <p:spPr>
           <a:xfrm>
             <a:off x="457200" y="457200"/>
-            <a:ext cx="17373600" cy="9372600"/>
+            <a:ext cx="18379440" cy="8503920"/>
           </a:xfrm>
           <a:prstGeom prst="rect">
             <a:avLst/>
@@ -3141,7 +3141,7 @@
         <p:spPr>
           <a:xfrm>
             <a:off x="5486400" y="45720"/>
-            <a:ext cx="9144000" cy="365760"/>
+            <a:ext cx="10058400" cy="365760"/>
           </a:xfrm>
           <a:prstGeom prst="rect">
             <a:avLst/>
@@ -3175,8 +3175,8 @@
         </p:nvSpPr>
         <p:spPr>
           <a:xfrm>
-            <a:off x="15179040" y="54864"/>
-            <a:ext cx="2560320" cy="274320"/>
+            <a:off x="15910559" y="64008"/>
+            <a:ext cx="2926080" cy="274320"/>
           </a:xfrm>
           <a:prstGeom prst="rect">
             <a:avLst/>
@@ -3210,7 +3210,7 @@
         </p:nvSpPr>
         <p:spPr>
           <a:xfrm>
-            <a:off x="17373600" y="10104120"/>
+            <a:off x="18288000" y="9646920"/>
             <a:ext cx="2560320" cy="274320"/>
           </a:xfrm>
           <a:prstGeom prst="rect">
@@ -3605,7 +3605,7 @@
         </p:nvSpPr>
         <p:spPr>
           <a:xfrm>
-            <a:off x="14447520" y="2743200"/>
+            <a:off x="13898880" y="2743200"/>
             <a:ext cx="2377440" cy="1188720"/>
           </a:xfrm>
           <a:prstGeom prst="rect">
@@ -3660,7 +3660,7 @@
         </p:nvSpPr>
         <p:spPr>
           <a:xfrm>
-            <a:off x="16276320" y="3621024"/>
+            <a:off x="15727680" y="3621024"/>
             <a:ext cx="457200" cy="256032"/>
           </a:xfrm>
           <a:prstGeom prst="rect">
@@ -3695,7 +3695,7 @@
         </p:nvSpPr>
         <p:spPr>
           <a:xfrm>
-            <a:off x="14447520" y="6675120"/>
+            <a:off x="15727680" y="6675120"/>
             <a:ext cx="2377440" cy="1188720"/>
           </a:xfrm>
           <a:prstGeom prst="rect">
@@ -3750,7 +3750,7 @@
         </p:nvSpPr>
         <p:spPr>
           <a:xfrm>
-            <a:off x="16276320" y="7552944"/>
+            <a:off x="17556480" y="7552944"/>
             <a:ext cx="457200" cy="256032"/>
           </a:xfrm>
           <a:prstGeom prst="rect">
@@ -3780,13 +3780,16 @@
       <p:cxnSp>
         <p:nvCxnSpPr>
           <p:cNvPr id="18" name="Connector 17"/>
-          <p:cNvCxnSpPr/>
+          <p:cNvCxnSpPr>
+            <a:stCxn id="6" idx="1"/>
+            <a:endCxn id="8" idx="3"/>
+          </p:cNvCxnSpPr>
           <p:nvPr/>
         </p:nvCxnSpPr>
         <p:spPr>
           <a:xfrm>
-            <a:off x="4572000" y="5349240"/>
-            <a:ext cx="548640" cy="0"/>
+            <a:off x="2194560" y="5349240"/>
+            <a:ext cx="5303520" cy="0"/>
           </a:xfrm>
           <a:prstGeom prst="line">
             <a:avLst/>
@@ -3816,13 +3819,16 @@
       <p:cxnSp>
         <p:nvCxnSpPr>
           <p:cNvPr id="19" name="Connector 18"/>
-          <p:cNvCxnSpPr/>
+          <p:cNvCxnSpPr>
+            <a:stCxn id="8" idx="1"/>
+            <a:endCxn id="10" idx="3"/>
+          </p:cNvCxnSpPr>
           <p:nvPr/>
         </p:nvCxnSpPr>
         <p:spPr>
           <a:xfrm>
-            <a:off x="7498079" y="5349240"/>
-            <a:ext cx="548641" cy="0"/>
+            <a:off x="5120640" y="5349240"/>
+            <a:ext cx="5303520" cy="0"/>
           </a:xfrm>
           <a:prstGeom prst="line">
             <a:avLst/>
@@ -3852,13 +3858,16 @@
       <p:cxnSp>
         <p:nvCxnSpPr>
           <p:cNvPr id="20" name="Connector 19"/>
-          <p:cNvCxnSpPr/>
+          <p:cNvCxnSpPr>
+            <a:stCxn id="10" idx="1"/>
+            <a:endCxn id="12" idx="3"/>
+          </p:cNvCxnSpPr>
           <p:nvPr/>
         </p:nvCxnSpPr>
         <p:spPr>
           <a:xfrm>
-            <a:off x="10424160" y="5349240"/>
-            <a:ext cx="548640" cy="0"/>
+            <a:off x="8046720" y="5349240"/>
+            <a:ext cx="5303520" cy="0"/>
           </a:xfrm>
           <a:prstGeom prst="line">
             <a:avLst/>
@@ -3888,21 +3897,25 @@
       <p:cxnSp>
         <p:nvCxnSpPr>
           <p:cNvPr id="21" name="Connector 20"/>
-          <p:cNvCxnSpPr/>
+          <p:cNvCxnSpPr>
+            <a:stCxn id="12" idx="1"/>
+            <a:endCxn id="14" idx="3"/>
+          </p:cNvCxnSpPr>
           <p:nvPr/>
         </p:nvCxnSpPr>
         <p:spPr>
-          <a:xfrm>
-            <a:off x="13350240" y="5120640"/>
-            <a:ext cx="548640" cy="0"/>
-          </a:xfrm>
-          <a:prstGeom prst="line">
+          <a:xfrm flipV="1">
+            <a:off x="10972800" y="3337560"/>
+            <a:ext cx="5303520" cy="2011680"/>
+          </a:xfrm>
+          <a:prstGeom prst="bentConnector3">
             <a:avLst/>
           </a:prstGeom>
           <a:ln w="19050">
             <a:solidFill>
               <a:srgbClr val="000000"/>
             </a:solidFill>
+            <a:tailEnd type="triangle" w="med" len="med"/>
           </a:ln>
         </p:spPr>
         <p:style>
@@ -3923,21 +3936,238 @@
       <p:cxnSp>
         <p:nvCxnSpPr>
           <p:cNvPr id="22" name="Connector 21"/>
-          <p:cNvCxnSpPr/>
+          <p:cNvCxnSpPr>
+            <a:stCxn id="12" idx="1"/>
+            <a:endCxn id="16" idx="3"/>
+          </p:cNvCxnSpPr>
           <p:nvPr/>
         </p:nvCxnSpPr>
         <p:spPr>
-          <a:xfrm flipV="1">
-            <a:off x="13898880" y="3337560"/>
-            <a:ext cx="0" cy="1783080"/>
-          </a:xfrm>
-          <a:prstGeom prst="line">
+          <a:xfrm>
+            <a:off x="10972800" y="5349240"/>
+            <a:ext cx="7132320" cy="1920240"/>
+          </a:xfrm>
+          <a:prstGeom prst="bentConnector3">
             <a:avLst/>
           </a:prstGeom>
           <a:ln w="19050">
             <a:solidFill>
               <a:srgbClr val="000000"/>
             </a:solidFill>
+            <a:tailEnd type="triangle" w="med" len="med"/>
+          </a:ln>
+        </p:spPr>
+        <p:style>
+          <a:lnRef idx="2">
+            <a:schemeClr val="accent1"/>
+          </a:lnRef>
+          <a:fillRef idx="0">
+            <a:schemeClr val="accent1"/>
+          </a:fillRef>
+          <a:effectRef idx="1">
+            <a:schemeClr val="accent1"/>
+          </a:effectRef>
+          <a:fontRef idx="minor">
+            <a:schemeClr val="tx1"/>
+          </a:fontRef>
+        </p:style>
+      </p:cxnSp>
+      <p:sp>
+        <p:nvSpPr>
+          <p:cNvPr id="23" name="TextBox 22"/>
+          <p:cNvSpPr txBox="1"/>
+          <p:nvPr/>
+        </p:nvSpPr>
+        <p:spPr>
+          <a:xfrm>
+            <a:off x="3566160" y="4160520"/>
+            <a:ext cx="2560320" cy="457200"/>
+          </a:xfrm>
+          <a:prstGeom prst="rect">
+            <a:avLst/>
+          </a:prstGeom>
+          <a:noFill/>
+        </p:spPr>
+        <p:txBody>
+          <a:bodyPr wrap="square" anchor="t" lIns="12700" rIns="12700" tIns="12700" bIns="12700">
+            <a:spAutoFit/>
+          </a:bodyPr>
+          <a:lstStyle/>
+          <a:p>
+            <a:pPr algn="ctr"/>
+            <a:r>
+              <a:rPr sz="900" b="0">
+                <a:solidFill>
+                  <a:srgbClr val="000000"/>
+                </a:solidFill>
+                <a:latin typeface="Arial"/>
+              </a:rPr>
+              <a:t>F1 Time/Geo-Tagged, Quality-Checked Observations (IER-03)</a:t>
+            </a:r>
+          </a:p>
+        </p:txBody>
+      </p:sp>
+      <p:sp>
+        <p:nvSpPr>
+          <p:cNvPr id="24" name="TextBox 23"/>
+          <p:cNvSpPr txBox="1"/>
+          <p:nvPr/>
+        </p:nvSpPr>
+        <p:spPr>
+          <a:xfrm>
+            <a:off x="6492240" y="3977639"/>
+            <a:ext cx="2560320" cy="457200"/>
+          </a:xfrm>
+          <a:prstGeom prst="rect">
+            <a:avLst/>
+          </a:prstGeom>
+          <a:noFill/>
+        </p:spPr>
+        <p:txBody>
+          <a:bodyPr wrap="square" anchor="t" lIns="12700" rIns="12700" tIns="12700" bIns="12700">
+            <a:spAutoFit/>
+          </a:bodyPr>
+          <a:lstStyle/>
+          <a:p>
+            <a:pPr algn="ctr"/>
+            <a:r>
+              <a:rPr sz="900" b="0">
+                <a:solidFill>
+                  <a:srgbClr val="000000"/>
+                </a:solidFill>
+                <a:latin typeface="Arial"/>
+              </a:rPr>
+              <a:t>F2 Local Micro-Weather State Estimate (IER-05)</a:t>
+            </a:r>
+          </a:p>
+        </p:txBody>
+      </p:sp>
+      <p:sp>
+        <p:nvSpPr>
+          <p:cNvPr id="25" name="TextBox 24"/>
+          <p:cNvSpPr txBox="1"/>
+          <p:nvPr/>
+        </p:nvSpPr>
+        <p:spPr>
+          <a:xfrm>
+            <a:off x="8686800" y="4160520"/>
+            <a:ext cx="2377440" cy="457200"/>
+          </a:xfrm>
+          <a:prstGeom prst="rect">
+            <a:avLst/>
+          </a:prstGeom>
+          <a:noFill/>
+        </p:spPr>
+        <p:txBody>
+          <a:bodyPr wrap="square" anchor="t" lIns="12700" rIns="12700" tIns="12700" bIns="12700">
+            <a:spAutoFit/>
+          </a:bodyPr>
+          <a:lstStyle/>
+          <a:p>
+            <a:pPr algn="ctr"/>
+            <a:r>
+              <a:rPr sz="900" b="0">
+                <a:solidFill>
+                  <a:srgbClr val="000000"/>
+                </a:solidFill>
+                <a:latin typeface="Arial"/>
+              </a:rPr>
+              <a:t>F3 Confidence Bounds &amp; Risk Envelopes (IER-09)</a:t>
+            </a:r>
+          </a:p>
+        </p:txBody>
+      </p:sp>
+      <p:sp>
+        <p:nvSpPr>
+          <p:cNvPr id="26" name="TextBox 25"/>
+          <p:cNvSpPr txBox="1"/>
+          <p:nvPr/>
+        </p:nvSpPr>
+        <p:spPr>
+          <a:xfrm>
+            <a:off x="12527280" y="2148840"/>
+            <a:ext cx="2103120" cy="457200"/>
+          </a:xfrm>
+          <a:prstGeom prst="rect">
+            <a:avLst/>
+          </a:prstGeom>
+          <a:noFill/>
+        </p:spPr>
+        <p:txBody>
+          <a:bodyPr wrap="square" anchor="t" lIns="12700" rIns="12700" tIns="12700" bIns="12700">
+            <a:spAutoFit/>
+          </a:bodyPr>
+          <a:lstStyle/>
+          <a:p>
+            <a:pPr algn="l"/>
+            <a:r>
+              <a:rPr sz="900" b="0">
+                <a:solidFill>
+                  <a:srgbClr val="000000"/>
+                </a:solidFill>
+                <a:latin typeface="Arial"/>
+              </a:rPr>
+              <a:t>F4 Federated Weather Context / COWP State</a:t>
+            </a:r>
+          </a:p>
+        </p:txBody>
+      </p:sp>
+      <p:sp>
+        <p:nvSpPr>
+          <p:cNvPr id="27" name="TextBox 26"/>
+          <p:cNvSpPr txBox="1"/>
+          <p:nvPr/>
+        </p:nvSpPr>
+        <p:spPr>
+          <a:xfrm>
+            <a:off x="9692640" y="6537960"/>
+            <a:ext cx="2377440" cy="457200"/>
+          </a:xfrm>
+          <a:prstGeom prst="rect">
+            <a:avLst/>
+          </a:prstGeom>
+          <a:noFill/>
+        </p:spPr>
+        <p:txBody>
+          <a:bodyPr wrap="square" anchor="t" lIns="12700" rIns="12700" tIns="12700" bIns="12700">
+            <a:spAutoFit/>
+          </a:bodyPr>
+          <a:lstStyle/>
+          <a:p>
+            <a:pPr algn="l"/>
+            <a:r>
+              <a:rPr sz="900" b="0">
+                <a:solidFill>
+                  <a:srgbClr val="000000"/>
+                </a:solidFill>
+                <a:latin typeface="Arial"/>
+              </a:rPr>
+              <a:t>F5 Federated Weather Context / COWP State</a:t>
+            </a:r>
+          </a:p>
+        </p:txBody>
+      </p:sp>
+      <p:cxnSp>
+        <p:nvCxnSpPr>
+          <p:cNvPr id="28" name="Connector 27"/>
+          <p:cNvCxnSpPr>
+            <a:endCxn id="6" idx="3"/>
+          </p:cNvCxnSpPr>
+          <p:nvPr/>
+        </p:nvCxnSpPr>
+        <p:spPr>
+          <a:xfrm>
+            <a:off x="457200" y="5029200"/>
+            <a:ext cx="4114800" cy="320040"/>
+          </a:xfrm>
+          <a:prstGeom prst="bentConnector3">
+            <a:avLst/>
+          </a:prstGeom>
+          <a:ln w="19050">
+            <a:solidFill>
+              <a:srgbClr val="000000"/>
+            </a:solidFill>
+            <a:tailEnd type="triangle" w="med" len="med"/>
           </a:ln>
         </p:spPr>
         <p:style>
@@ -3957,16 +4187,18 @@
       </p:cxnSp>
       <p:cxnSp>
         <p:nvCxnSpPr>
-          <p:cNvPr id="23" name="Connector 22"/>
-          <p:cNvCxnSpPr/>
+          <p:cNvPr id="29" name="Connector 28"/>
+          <p:cNvCxnSpPr>
+            <a:endCxn id="6" idx="3"/>
+          </p:cNvCxnSpPr>
           <p:nvPr/>
         </p:nvCxnSpPr>
         <p:spPr>
-          <a:xfrm>
-            <a:off x="13898880" y="3337560"/>
-            <a:ext cx="548640" cy="0"/>
-          </a:xfrm>
-          <a:prstGeom prst="line">
+          <a:xfrm flipV="1">
+            <a:off x="457200" y="5349240"/>
+            <a:ext cx="4114800" cy="320040"/>
+          </a:xfrm>
+          <a:prstGeom prst="bentConnector3">
             <a:avLst/>
           </a:prstGeom>
           <a:ln w="19050">
@@ -3993,14 +4225,16 @@
       </p:cxnSp>
       <p:cxnSp>
         <p:nvCxnSpPr>
-          <p:cNvPr id="24" name="Connector 23"/>
-          <p:cNvCxnSpPr/>
+          <p:cNvPr id="30" name="Connector 29"/>
+          <p:cNvCxnSpPr>
+            <a:endCxn id="14" idx="3"/>
+          </p:cNvCxnSpPr>
           <p:nvPr/>
         </p:nvCxnSpPr>
         <p:spPr>
           <a:xfrm>
-            <a:off x="13350240" y="5577840"/>
-            <a:ext cx="548640" cy="0"/>
+            <a:off x="457200" y="3337560"/>
+            <a:ext cx="15819120" cy="0"/>
           </a:xfrm>
           <a:prstGeom prst="line">
             <a:avLst/>
@@ -4009,6 +4243,7 @@
             <a:solidFill>
               <a:srgbClr val="000000"/>
             </a:solidFill>
+            <a:tailEnd type="triangle" w="med" len="med"/>
           </a:ln>
         </p:spPr>
         <p:style>
@@ -4028,14 +4263,16 @@
       </p:cxnSp>
       <p:cxnSp>
         <p:nvCxnSpPr>
-          <p:cNvPr id="25" name="Connector 24"/>
-          <p:cNvCxnSpPr/>
+          <p:cNvPr id="31" name="Connector 30"/>
+          <p:cNvCxnSpPr>
+            <a:endCxn id="16" idx="3"/>
+          </p:cNvCxnSpPr>
           <p:nvPr/>
         </p:nvCxnSpPr>
         <p:spPr>
           <a:xfrm>
-            <a:off x="13898880" y="5577840"/>
-            <a:ext cx="0" cy="1691640"/>
+            <a:off x="457200" y="7269480"/>
+            <a:ext cx="17647920" cy="0"/>
           </a:xfrm>
           <a:prstGeom prst="line">
             <a:avLst/>
@@ -4044,6 +4281,7 @@
             <a:solidFill>
               <a:srgbClr val="000000"/>
             </a:solidFill>
+            <a:tailEnd type="triangle" w="med" len="med"/>
           </a:ln>
         </p:spPr>
         <p:style>
@@ -4061,52 +4299,16 @@
           </a:fontRef>
         </p:style>
       </p:cxnSp>
-      <p:cxnSp>
-        <p:nvCxnSpPr>
-          <p:cNvPr id="26" name="Connector 25"/>
-          <p:cNvCxnSpPr/>
-          <p:nvPr/>
-        </p:nvCxnSpPr>
-        <p:spPr>
-          <a:xfrm>
-            <a:off x="13898880" y="7269480"/>
-            <a:ext cx="548640" cy="0"/>
-          </a:xfrm>
-          <a:prstGeom prst="line">
-            <a:avLst/>
-          </a:prstGeom>
-          <a:ln w="19050">
-            <a:solidFill>
-              <a:srgbClr val="000000"/>
-            </a:solidFill>
-            <a:tailEnd type="triangle" w="med" len="med"/>
-          </a:ln>
-        </p:spPr>
-        <p:style>
-          <a:lnRef idx="2">
-            <a:schemeClr val="accent1"/>
-          </a:lnRef>
-          <a:fillRef idx="0">
-            <a:schemeClr val="accent1"/>
-          </a:fillRef>
-          <a:effectRef idx="1">
-            <a:schemeClr val="accent1"/>
-          </a:effectRef>
-          <a:fontRef idx="minor">
-            <a:schemeClr val="tx1"/>
-          </a:fontRef>
-        </p:style>
-      </p:cxnSp>
-      <p:sp>
-        <p:nvSpPr>
-          <p:cNvPr id="27" name="TextBox 26"/>
+      <p:sp>
+        <p:nvSpPr>
+          <p:cNvPr id="32" name="TextBox 31"/>
           <p:cNvSpPr txBox="1"/>
           <p:nvPr/>
         </p:nvSpPr>
         <p:spPr>
           <a:xfrm>
-            <a:off x="3566160" y="4160520"/>
-            <a:ext cx="2560320" cy="457200"/>
+            <a:off x="548640" y="4681728"/>
+            <a:ext cx="1554480" cy="365760"/>
           </a:xfrm>
           <a:prstGeom prst="rect">
             <a:avLst/>
@@ -4119,7 +4321,7 @@
           </a:bodyPr>
           <a:lstStyle/>
           <a:p>
-            <a:pPr algn="ctr"/>
+            <a:pPr algn="l"/>
             <a:r>
               <a:rPr sz="900" b="0">
                 <a:solidFill>
@@ -4127,21 +4329,21 @@
                 </a:solidFill>
                 <a:latin typeface="Arial"/>
               </a:rPr>
-              <a:t>F1 Time/Geo-Tagged, Quality-Checked Observations (IER-03)</a:t>
-            </a:r>
-          </a:p>
-        </p:txBody>
-      </p:sp>
-      <p:sp>
-        <p:nvSpPr>
-          <p:cNvPr id="28" name="TextBox 27"/>
+              <a:t>I1 Collocated Atmospheric Observations</a:t>
+            </a:r>
+          </a:p>
+        </p:txBody>
+      </p:sp>
+      <p:sp>
+        <p:nvSpPr>
+          <p:cNvPr id="33" name="TextBox 32"/>
           <p:cNvSpPr txBox="1"/>
           <p:nvPr/>
         </p:nvSpPr>
         <p:spPr>
           <a:xfrm>
-            <a:off x="6492240" y="3977639"/>
-            <a:ext cx="2560320" cy="457200"/>
+            <a:off x="548640" y="5715000"/>
+            <a:ext cx="1554480" cy="365760"/>
           </a:xfrm>
           <a:prstGeom prst="rect">
             <a:avLst/>
@@ -4154,7 +4356,7 @@
           </a:bodyPr>
           <a:lstStyle/>
           <a:p>
-            <a:pPr algn="ctr"/>
+            <a:pPr algn="l"/>
             <a:r>
               <a:rPr sz="900" b="0">
                 <a:solidFill>
@@ -4162,21 +4364,21 @@
                 </a:solidFill>
                 <a:latin typeface="Arial"/>
               </a:rPr>
-              <a:t>F2 Local Micro-Weather State Estimate (IER-05)</a:t>
-            </a:r>
-          </a:p>
-        </p:txBody>
-      </p:sp>
-      <p:sp>
-        <p:nvSpPr>
-          <p:cNvPr id="29" name="TextBox 28"/>
+              <a:t>I2 Peer Platform Weather Observations</a:t>
+            </a:r>
+          </a:p>
+        </p:txBody>
+      </p:sp>
+      <p:sp>
+        <p:nvSpPr>
+          <p:cNvPr id="34" name="TextBox 33"/>
           <p:cNvSpPr txBox="1"/>
           <p:nvPr/>
         </p:nvSpPr>
         <p:spPr>
           <a:xfrm>
-            <a:off x="9418320" y="4160520"/>
-            <a:ext cx="2560320" cy="457200"/>
+            <a:off x="548640" y="3017520"/>
+            <a:ext cx="2651760" cy="310896"/>
           </a:xfrm>
           <a:prstGeom prst="rect">
             <a:avLst/>
@@ -4189,7 +4391,7 @@
           </a:bodyPr>
           <a:lstStyle/>
           <a:p>
-            <a:pPr algn="ctr"/>
+            <a:pPr algn="l"/>
             <a:r>
               <a:rPr sz="900" b="0">
                 <a:solidFill>
@@ -4197,91 +4399,23 @@
                 </a:solidFill>
                 <a:latin typeface="Arial"/>
               </a:rPr>
-              <a:t>F3 Confidence Bounds &amp; Risk Envelopes (IER-09)</a:t>
-            </a:r>
-          </a:p>
-        </p:txBody>
-      </p:sp>
-      <p:sp>
-        <p:nvSpPr>
-          <p:cNvPr id="30" name="TextBox 29"/>
-          <p:cNvSpPr txBox="1"/>
-          <p:nvPr/>
-        </p:nvSpPr>
-        <p:spPr>
-          <a:xfrm>
-            <a:off x="13258800" y="2286000"/>
-            <a:ext cx="2103120" cy="457200"/>
-          </a:xfrm>
-          <a:prstGeom prst="rect">
-            <a:avLst/>
-          </a:prstGeom>
-          <a:noFill/>
-        </p:spPr>
-        <p:txBody>
-          <a:bodyPr wrap="square" anchor="t" lIns="12700" rIns="12700" tIns="12700" bIns="12700">
-            <a:spAutoFit/>
-          </a:bodyPr>
-          <a:lstStyle/>
-          <a:p>
-            <a:pPr algn="l"/>
-            <a:r>
-              <a:rPr sz="900" b="0">
-                <a:solidFill>
-                  <a:srgbClr val="000000"/>
-                </a:solidFill>
-                <a:latin typeface="Arial"/>
-              </a:rPr>
-              <a:t>F4 Federated Weather Context / COWP State</a:t>
-            </a:r>
-          </a:p>
-        </p:txBody>
-      </p:sp>
-      <p:sp>
-        <p:nvSpPr>
-          <p:cNvPr id="31" name="TextBox 30"/>
-          <p:cNvSpPr txBox="1"/>
-          <p:nvPr/>
-        </p:nvSpPr>
-        <p:spPr>
-          <a:xfrm>
-            <a:off x="14447520" y="6236208"/>
-            <a:ext cx="2194560" cy="411480"/>
-          </a:xfrm>
-          <a:prstGeom prst="rect">
-            <a:avLst/>
-          </a:prstGeom>
-          <a:noFill/>
-        </p:spPr>
-        <p:txBody>
-          <a:bodyPr wrap="square" anchor="t" lIns="12700" rIns="12700" tIns="12700" bIns="12700">
-            <a:spAutoFit/>
-          </a:bodyPr>
-          <a:lstStyle/>
-          <a:p>
-            <a:pPr algn="l"/>
-            <a:r>
-              <a:rPr sz="900" b="0">
-                <a:solidFill>
-                  <a:srgbClr val="000000"/>
-                </a:solidFill>
-                <a:latin typeface="Arial"/>
-              </a:rPr>
-              <a:t>F5 Federated Weather Context / COWP State</a:t>
+              <a:t>I3 Mission Weather Threshold Definitions</a:t>
             </a:r>
           </a:p>
         </p:txBody>
       </p:sp>
       <p:cxnSp>
         <p:nvCxnSpPr>
-          <p:cNvPr id="32" name="Connector 31"/>
-          <p:cNvCxnSpPr/>
+          <p:cNvPr id="35" name="Connector 34"/>
+          <p:cNvCxnSpPr>
+            <a:endCxn id="12" idx="0"/>
+          </p:cNvCxnSpPr>
           <p:nvPr/>
         </p:nvCxnSpPr>
         <p:spPr>
           <a:xfrm>
-            <a:off x="457200" y="5120640"/>
-            <a:ext cx="1737360" cy="0"/>
+            <a:off x="12161520" y="457200"/>
+            <a:ext cx="0" cy="4297680"/>
           </a:xfrm>
           <a:prstGeom prst="line">
             <a:avLst/>
@@ -4291,112 +4425,6 @@
               <a:srgbClr val="000000"/>
             </a:solidFill>
             <a:tailEnd type="triangle" w="med" len="med"/>
-          </a:ln>
-        </p:spPr>
-        <p:style>
-          <a:lnRef idx="2">
-            <a:schemeClr val="accent1"/>
-          </a:lnRef>
-          <a:fillRef idx="0">
-            <a:schemeClr val="accent1"/>
-          </a:fillRef>
-          <a:effectRef idx="1">
-            <a:schemeClr val="accent1"/>
-          </a:effectRef>
-          <a:fontRef idx="minor">
-            <a:schemeClr val="tx1"/>
-          </a:fontRef>
-        </p:style>
-      </p:cxnSp>
-      <p:cxnSp>
-        <p:nvCxnSpPr>
-          <p:cNvPr id="33" name="Connector 32"/>
-          <p:cNvCxnSpPr/>
-          <p:nvPr/>
-        </p:nvCxnSpPr>
-        <p:spPr>
-          <a:xfrm>
-            <a:off x="457200" y="5577840"/>
-            <a:ext cx="1737360" cy="0"/>
-          </a:xfrm>
-          <a:prstGeom prst="line">
-            <a:avLst/>
-          </a:prstGeom>
-          <a:ln w="19050">
-            <a:solidFill>
-              <a:srgbClr val="000000"/>
-            </a:solidFill>
-            <a:tailEnd type="triangle" w="med" len="med"/>
-          </a:ln>
-        </p:spPr>
-        <p:style>
-          <a:lnRef idx="2">
-            <a:schemeClr val="accent1"/>
-          </a:lnRef>
-          <a:fillRef idx="0">
-            <a:schemeClr val="accent1"/>
-          </a:fillRef>
-          <a:effectRef idx="1">
-            <a:schemeClr val="accent1"/>
-          </a:effectRef>
-          <a:fontRef idx="minor">
-            <a:schemeClr val="tx1"/>
-          </a:fontRef>
-        </p:style>
-      </p:cxnSp>
-      <p:cxnSp>
-        <p:nvCxnSpPr>
-          <p:cNvPr id="34" name="Connector 33"/>
-          <p:cNvCxnSpPr/>
-          <p:nvPr/>
-        </p:nvCxnSpPr>
-        <p:spPr>
-          <a:xfrm>
-            <a:off x="457200" y="8961120"/>
-            <a:ext cx="13533120" cy="0"/>
-          </a:xfrm>
-          <a:prstGeom prst="line">
-            <a:avLst/>
-          </a:prstGeom>
-          <a:ln w="19050">
-            <a:solidFill>
-              <a:srgbClr val="000000"/>
-            </a:solidFill>
-          </a:ln>
-        </p:spPr>
-        <p:style>
-          <a:lnRef idx="2">
-            <a:schemeClr val="accent1"/>
-          </a:lnRef>
-          <a:fillRef idx="0">
-            <a:schemeClr val="accent1"/>
-          </a:fillRef>
-          <a:effectRef idx="1">
-            <a:schemeClr val="accent1"/>
-          </a:effectRef>
-          <a:fontRef idx="minor">
-            <a:schemeClr val="tx1"/>
-          </a:fontRef>
-        </p:style>
-      </p:cxnSp>
-      <p:cxnSp>
-        <p:nvCxnSpPr>
-          <p:cNvPr id="35" name="Connector 34"/>
-          <p:cNvCxnSpPr/>
-          <p:nvPr/>
-        </p:nvCxnSpPr>
-        <p:spPr>
-          <a:xfrm flipV="1">
-            <a:off x="13716000" y="3520440"/>
-            <a:ext cx="0" cy="5440680"/>
-          </a:xfrm>
-          <a:prstGeom prst="line">
-            <a:avLst/>
-          </a:prstGeom>
-          <a:ln w="19050">
-            <a:solidFill>
-              <a:srgbClr val="000000"/>
-            </a:solidFill>
           </a:ln>
         </p:spPr>
         <p:style>
@@ -4417,15 +4445,17 @@
       <p:cxnSp>
         <p:nvCxnSpPr>
           <p:cNvPr id="36" name="Connector 35"/>
-          <p:cNvCxnSpPr/>
+          <p:cNvCxnSpPr>
+            <a:endCxn id="12" idx="0"/>
+          </p:cNvCxnSpPr>
           <p:nvPr/>
         </p:nvCxnSpPr>
         <p:spPr>
           <a:xfrm>
-            <a:off x="13716000" y="3520440"/>
-            <a:ext cx="731520" cy="0"/>
-          </a:xfrm>
-          <a:prstGeom prst="line">
+            <a:off x="11521440" y="457200"/>
+            <a:ext cx="640080" cy="4297680"/>
+          </a:xfrm>
+          <a:prstGeom prst="bentConnector3">
             <a:avLst/>
           </a:prstGeom>
           <a:ln w="19050">
@@ -4453,13 +4483,15 @@
       <p:cxnSp>
         <p:nvCxnSpPr>
           <p:cNvPr id="37" name="Connector 36"/>
-          <p:cNvCxnSpPr/>
+          <p:cNvCxnSpPr>
+            <a:endCxn id="16" idx="0"/>
+          </p:cNvCxnSpPr>
           <p:nvPr/>
         </p:nvCxnSpPr>
         <p:spPr>
-          <a:xfrm flipV="1">
-            <a:off x="13990320" y="7406640"/>
-            <a:ext cx="0" cy="1554480"/>
+          <a:xfrm>
+            <a:off x="16916400" y="457200"/>
+            <a:ext cx="0" cy="6217920"/>
           </a:xfrm>
           <a:prstGeom prst="line">
             <a:avLst/>
@@ -4468,6 +4500,7 @@
             <a:solidFill>
               <a:srgbClr val="000000"/>
             </a:solidFill>
+            <a:tailEnd type="triangle" w="med" len="med"/>
           </a:ln>
         </p:spPr>
         <p:style>
@@ -4488,154 +4521,15 @@
       <p:cxnSp>
         <p:nvCxnSpPr>
           <p:cNvPr id="38" name="Connector 37"/>
-          <p:cNvCxnSpPr/>
+          <p:cNvCxnSpPr>
+            <a:endCxn id="14" idx="0"/>
+          </p:cNvCxnSpPr>
           <p:nvPr/>
         </p:nvCxnSpPr>
         <p:spPr>
           <a:xfrm>
-            <a:off x="13990320" y="7406640"/>
-            <a:ext cx="457200" cy="0"/>
-          </a:xfrm>
-          <a:prstGeom prst="line">
-            <a:avLst/>
-          </a:prstGeom>
-          <a:ln w="19050">
-            <a:solidFill>
-              <a:srgbClr val="000000"/>
-            </a:solidFill>
-            <a:tailEnd type="triangle" w="med" len="med"/>
-          </a:ln>
-        </p:spPr>
-        <p:style>
-          <a:lnRef idx="2">
-            <a:schemeClr val="accent1"/>
-          </a:lnRef>
-          <a:fillRef idx="0">
-            <a:schemeClr val="accent1"/>
-          </a:fillRef>
-          <a:effectRef idx="1">
-            <a:schemeClr val="accent1"/>
-          </a:effectRef>
-          <a:fontRef idx="minor">
-            <a:schemeClr val="tx1"/>
-          </a:fontRef>
-        </p:style>
-      </p:cxnSp>
-      <p:sp>
-        <p:nvSpPr>
-          <p:cNvPr id="39" name="TextBox 38"/>
-          <p:cNvSpPr txBox="1"/>
-          <p:nvPr/>
-        </p:nvSpPr>
-        <p:spPr>
-          <a:xfrm>
-            <a:off x="502920" y="4736592"/>
-            <a:ext cx="1691640" cy="365760"/>
-          </a:xfrm>
-          <a:prstGeom prst="rect">
-            <a:avLst/>
-          </a:prstGeom>
-          <a:noFill/>
-        </p:spPr>
-        <p:txBody>
-          <a:bodyPr wrap="square" anchor="t" lIns="12700" rIns="12700" tIns="12700" bIns="12700">
-            <a:spAutoFit/>
-          </a:bodyPr>
-          <a:lstStyle/>
-          <a:p>
-            <a:pPr algn="l"/>
-            <a:r>
-              <a:rPr sz="900" b="0">
-                <a:solidFill>
-                  <a:srgbClr val="000000"/>
-                </a:solidFill>
-                <a:latin typeface="Arial"/>
-              </a:rPr>
-              <a:t>I1 Collocated Atmospheric Observations</a:t>
-            </a:r>
-          </a:p>
-        </p:txBody>
-      </p:sp>
-      <p:sp>
-        <p:nvSpPr>
-          <p:cNvPr id="40" name="TextBox 39"/>
-          <p:cNvSpPr txBox="1"/>
-          <p:nvPr/>
-        </p:nvSpPr>
-        <p:spPr>
-          <a:xfrm>
-            <a:off x="502920" y="5596128"/>
-            <a:ext cx="1691640" cy="365760"/>
-          </a:xfrm>
-          <a:prstGeom prst="rect">
-            <a:avLst/>
-          </a:prstGeom>
-          <a:noFill/>
-        </p:spPr>
-        <p:txBody>
-          <a:bodyPr wrap="square" anchor="t" lIns="12700" rIns="12700" tIns="12700" bIns="12700">
-            <a:spAutoFit/>
-          </a:bodyPr>
-          <a:lstStyle/>
-          <a:p>
-            <a:pPr algn="l"/>
-            <a:r>
-              <a:rPr sz="900" b="0">
-                <a:solidFill>
-                  <a:srgbClr val="000000"/>
-                </a:solidFill>
-                <a:latin typeface="Arial"/>
-              </a:rPr>
-              <a:t>I2 Peer Platform Weather Observations</a:t>
-            </a:r>
-          </a:p>
-        </p:txBody>
-      </p:sp>
-      <p:sp>
-        <p:nvSpPr>
-          <p:cNvPr id="41" name="TextBox 40"/>
-          <p:cNvSpPr txBox="1"/>
-          <p:nvPr/>
-        </p:nvSpPr>
-        <p:spPr>
-          <a:xfrm>
-            <a:off x="502920" y="8613648"/>
-            <a:ext cx="2651760" cy="310896"/>
-          </a:xfrm>
-          <a:prstGeom prst="rect">
-            <a:avLst/>
-          </a:prstGeom>
-          <a:noFill/>
-        </p:spPr>
-        <p:txBody>
-          <a:bodyPr wrap="square" anchor="t" lIns="12700" rIns="12700" tIns="12700" bIns="12700">
-            <a:spAutoFit/>
-          </a:bodyPr>
-          <a:lstStyle/>
-          <a:p>
-            <a:pPr algn="l"/>
-            <a:r>
-              <a:rPr sz="900" b="0">
-                <a:solidFill>
-                  <a:srgbClr val="000000"/>
-                </a:solidFill>
-                <a:latin typeface="Arial"/>
-              </a:rPr>
-              <a:t>I3 Mission Weather Threshold Definitions</a:t>
-            </a:r>
-          </a:p>
-        </p:txBody>
-      </p:sp>
-      <p:cxnSp>
-        <p:nvCxnSpPr>
-          <p:cNvPr id="42" name="Connector 41"/>
-          <p:cNvCxnSpPr/>
-          <p:nvPr/>
-        </p:nvCxnSpPr>
-        <p:spPr>
-          <a:xfrm>
-            <a:off x="12161520" y="457200"/>
-            <a:ext cx="0" cy="4297680"/>
+            <a:off x="15087600" y="457200"/>
+            <a:ext cx="0" cy="2286000"/>
           </a:xfrm>
           <a:prstGeom prst="line">
             <a:avLst/>
@@ -4664,22 +4558,168 @@
       </p:cxnSp>
       <p:cxnSp>
         <p:nvCxnSpPr>
-          <p:cNvPr id="43" name="Connector 42"/>
-          <p:cNvCxnSpPr/>
+          <p:cNvPr id="39" name="Connector 38"/>
+          <p:cNvCxnSpPr>
+            <a:endCxn id="16" idx="0"/>
+          </p:cNvCxnSpPr>
           <p:nvPr/>
         </p:nvCxnSpPr>
         <p:spPr>
-          <a:xfrm>
-            <a:off x="11521440" y="457200"/>
-            <a:ext cx="0" cy="457200"/>
-          </a:xfrm>
-          <a:prstGeom prst="line">
+          <a:xfrm flipH="1">
+            <a:off x="16916400" y="457200"/>
+            <a:ext cx="365760" cy="6217920"/>
+          </a:xfrm>
+          <a:prstGeom prst="bentConnector3">
             <a:avLst/>
           </a:prstGeom>
           <a:ln w="19050">
             <a:solidFill>
               <a:srgbClr val="000000"/>
             </a:solidFill>
+            <a:tailEnd type="triangle" w="med" len="med"/>
+          </a:ln>
+        </p:spPr>
+        <p:style>
+          <a:lnRef idx="2">
+            <a:schemeClr val="accent1"/>
+          </a:lnRef>
+          <a:fillRef idx="0">
+            <a:schemeClr val="accent1"/>
+          </a:fillRef>
+          <a:effectRef idx="1">
+            <a:schemeClr val="accent1"/>
+          </a:effectRef>
+          <a:fontRef idx="minor">
+            <a:schemeClr val="tx1"/>
+          </a:fontRef>
+        </p:style>
+      </p:cxnSp>
+      <p:sp>
+        <p:nvSpPr>
+          <p:cNvPr id="40" name="TextBox 39"/>
+          <p:cNvSpPr txBox="1"/>
+          <p:nvPr/>
+        </p:nvSpPr>
+        <p:spPr>
+          <a:xfrm>
+            <a:off x="9418320" y="118872"/>
+            <a:ext cx="2194560" cy="310896"/>
+          </a:xfrm>
+          <a:prstGeom prst="rect">
+            <a:avLst/>
+          </a:prstGeom>
+          <a:noFill/>
+        </p:spPr>
+        <p:txBody>
+          <a:bodyPr wrap="square" anchor="t" lIns="12700" rIns="12700" tIns="12700" bIns="12700">
+            <a:spAutoFit/>
+          </a:bodyPr>
+          <a:lstStyle/>
+          <a:p>
+            <a:pPr algn="ctr"/>
+            <a:r>
+              <a:rPr sz="900" b="0">
+                <a:solidFill>
+                  <a:srgbClr val="000000"/>
+                </a:solidFill>
+                <a:latin typeface="Arial"/>
+              </a:rPr>
+              <a:t>C2 OPSEC / classification guidance</a:t>
+            </a:r>
+          </a:p>
+        </p:txBody>
+      </p:sp>
+      <p:sp>
+        <p:nvSpPr>
+          <p:cNvPr id="41" name="TextBox 40"/>
+          <p:cNvSpPr txBox="1"/>
+          <p:nvPr/>
+        </p:nvSpPr>
+        <p:spPr>
+          <a:xfrm>
+            <a:off x="11795760" y="118872"/>
+            <a:ext cx="2377440" cy="310896"/>
+          </a:xfrm>
+          <a:prstGeom prst="rect">
+            <a:avLst/>
+          </a:prstGeom>
+          <a:noFill/>
+        </p:spPr>
+        <p:txBody>
+          <a:bodyPr wrap="square" anchor="t" lIns="12700" rIns="12700" tIns="12700" bIns="12700">
+            <a:spAutoFit/>
+          </a:bodyPr>
+          <a:lstStyle/>
+          <a:p>
+            <a:pPr algn="ctr"/>
+            <a:r>
+              <a:rPr sz="900" b="0">
+                <a:solidFill>
+                  <a:srgbClr val="000000"/>
+                </a:solidFill>
+                <a:latin typeface="Arial"/>
+              </a:rPr>
+              <a:t>C3 Network availability and DDS QoS policies</a:t>
+            </a:r>
+          </a:p>
+        </p:txBody>
+      </p:sp>
+      <p:sp>
+        <p:nvSpPr>
+          <p:cNvPr id="42" name="TextBox 41"/>
+          <p:cNvSpPr txBox="1"/>
+          <p:nvPr/>
+        </p:nvSpPr>
+        <p:spPr>
+          <a:xfrm>
+            <a:off x="14538960" y="118872"/>
+            <a:ext cx="2743200" cy="310896"/>
+          </a:xfrm>
+          <a:prstGeom prst="rect">
+            <a:avLst/>
+          </a:prstGeom>
+          <a:noFill/>
+        </p:spPr>
+        <p:txBody>
+          <a:bodyPr wrap="square" anchor="t" lIns="12700" rIns="12700" tIns="12700" bIns="12700">
+            <a:spAutoFit/>
+          </a:bodyPr>
+          <a:lstStyle/>
+          <a:p>
+            <a:pPr algn="ctr"/>
+            <a:r>
+              <a:rPr sz="900" b="0">
+                <a:solidFill>
+                  <a:srgbClr val="000000"/>
+                </a:solidFill>
+                <a:latin typeface="Arial"/>
+              </a:rPr>
+              <a:t>C1 Mission objectives and operational constraints</a:t>
+            </a:r>
+          </a:p>
+        </p:txBody>
+      </p:sp>
+      <p:cxnSp>
+        <p:nvCxnSpPr>
+          <p:cNvPr id="43" name="Connector 42"/>
+          <p:cNvCxnSpPr>
+            <a:stCxn id="12" idx="1"/>
+          </p:cNvCxnSpPr>
+          <p:nvPr/>
+        </p:nvCxnSpPr>
+        <p:spPr>
+          <a:xfrm>
+            <a:off x="10972800" y="5349240"/>
+            <a:ext cx="7863840" cy="0"/>
+          </a:xfrm>
+          <a:prstGeom prst="line">
+            <a:avLst/>
+          </a:prstGeom>
+          <a:ln w="19050">
+            <a:solidFill>
+              <a:srgbClr val="000000"/>
+            </a:solidFill>
+            <a:tailEnd type="triangle" w="med" len="med"/>
           </a:ln>
         </p:spPr>
         <p:style>
@@ -4700,13 +4740,15 @@
       <p:cxnSp>
         <p:nvCxnSpPr>
           <p:cNvPr id="44" name="Connector 43"/>
-          <p:cNvCxnSpPr/>
+          <p:cNvCxnSpPr>
+            <a:stCxn id="14" idx="1"/>
+          </p:cNvCxnSpPr>
           <p:nvPr/>
         </p:nvCxnSpPr>
         <p:spPr>
           <a:xfrm>
-            <a:off x="11521440" y="914400"/>
-            <a:ext cx="0" cy="3840480"/>
+            <a:off x="13898880" y="3337560"/>
+            <a:ext cx="4937760" cy="0"/>
           </a:xfrm>
           <a:prstGeom prst="line">
             <a:avLst/>
@@ -4736,13 +4778,15 @@
       <p:cxnSp>
         <p:nvCxnSpPr>
           <p:cNvPr id="45" name="Connector 44"/>
-          <p:cNvCxnSpPr/>
+          <p:cNvCxnSpPr>
+            <a:stCxn id="16" idx="1"/>
+          </p:cNvCxnSpPr>
           <p:nvPr/>
         </p:nvCxnSpPr>
         <p:spPr>
           <a:xfrm>
-            <a:off x="11521440" y="914400"/>
-            <a:ext cx="5852160" cy="0"/>
+            <a:off x="15727680" y="7269480"/>
+            <a:ext cx="3108960" cy="0"/>
           </a:xfrm>
           <a:prstGeom prst="line">
             <a:avLst/>
@@ -4751,6 +4795,7 @@
             <a:solidFill>
               <a:srgbClr val="000000"/>
             </a:solidFill>
+            <a:tailEnd type="triangle" w="med" len="med"/>
           </a:ln>
         </p:spPr>
         <p:style>
@@ -4768,86 +4813,123 @@
           </a:fontRef>
         </p:style>
       </p:cxnSp>
+      <p:sp>
+        <p:nvSpPr>
+          <p:cNvPr id="46" name="TextBox 45"/>
+          <p:cNvSpPr txBox="1"/>
+          <p:nvPr/>
+        </p:nvSpPr>
+        <p:spPr>
+          <a:xfrm>
+            <a:off x="18928080" y="5120640"/>
+            <a:ext cx="2011680" cy="457200"/>
+          </a:xfrm>
+          <a:prstGeom prst="rect">
+            <a:avLst/>
+          </a:prstGeom>
+          <a:noFill/>
+        </p:spPr>
+        <p:txBody>
+          <a:bodyPr wrap="square" anchor="t" lIns="12700" rIns="12700" tIns="12700" bIns="12700">
+            <a:spAutoFit/>
+          </a:bodyPr>
+          <a:lstStyle/>
+          <a:p>
+            <a:pPr algn="l"/>
+            <a:r>
+              <a:rPr sz="900" b="0">
+                <a:solidFill>
+                  <a:srgbClr val="000000"/>
+                </a:solidFill>
+                <a:latin typeface="Arial"/>
+              </a:rPr>
+              <a:t>O1 Fused COWP State</a:t>
+            </a:r>
+          </a:p>
+        </p:txBody>
+      </p:sp>
+      <p:sp>
+        <p:nvSpPr>
+          <p:cNvPr id="47" name="TextBox 46"/>
+          <p:cNvSpPr txBox="1"/>
+          <p:nvPr/>
+        </p:nvSpPr>
+        <p:spPr>
+          <a:xfrm>
+            <a:off x="18928080" y="3108960"/>
+            <a:ext cx="2011680" cy="457200"/>
+          </a:xfrm>
+          <a:prstGeom prst="rect">
+            <a:avLst/>
+          </a:prstGeom>
+          <a:noFill/>
+        </p:spPr>
+        <p:txBody>
+          <a:bodyPr wrap="square" anchor="t" lIns="12700" rIns="12700" tIns="12700" bIns="12700">
+            <a:spAutoFit/>
+          </a:bodyPr>
+          <a:lstStyle/>
+          <a:p>
+            <a:pPr algn="l"/>
+            <a:r>
+              <a:rPr sz="900" b="0">
+                <a:solidFill>
+                  <a:srgbClr val="000000"/>
+                </a:solidFill>
+                <a:latin typeface="Arial"/>
+              </a:rPr>
+              <a:t>O3 Weather State Change Notifications</a:t>
+            </a:r>
+          </a:p>
+        </p:txBody>
+      </p:sp>
+      <p:sp>
+        <p:nvSpPr>
+          <p:cNvPr id="48" name="TextBox 47"/>
+          <p:cNvSpPr txBox="1"/>
+          <p:nvPr/>
+        </p:nvSpPr>
+        <p:spPr>
+          <a:xfrm>
+            <a:off x="18928080" y="7040880"/>
+            <a:ext cx="2011680" cy="457200"/>
+          </a:xfrm>
+          <a:prstGeom prst="rect">
+            <a:avLst/>
+          </a:prstGeom>
+          <a:noFill/>
+        </p:spPr>
+        <p:txBody>
+          <a:bodyPr wrap="square" anchor="t" lIns="12700" rIns="12700" tIns="12700" bIns="12700">
+            <a:spAutoFit/>
+          </a:bodyPr>
+          <a:lstStyle/>
+          <a:p>
+            <a:pPr algn="l"/>
+            <a:r>
+              <a:rPr sz="900" b="0">
+                <a:solidFill>
+                  <a:srgbClr val="000000"/>
+                </a:solidFill>
+                <a:latin typeface="Arial"/>
+              </a:rPr>
+              <a:t>O2 Mission-Tailored COWP Excerpts</a:t>
+            </a:r>
+          </a:p>
+        </p:txBody>
+      </p:sp>
       <p:cxnSp>
         <p:nvCxnSpPr>
-          <p:cNvPr id="46" name="Connector 45"/>
-          <p:cNvCxnSpPr/>
+          <p:cNvPr id="49" name="Connector 48"/>
+          <p:cNvCxnSpPr>
+            <a:endCxn id="6" idx="2"/>
+          </p:cNvCxnSpPr>
           <p:nvPr/>
         </p:nvCxnSpPr>
         <p:spPr>
-          <a:xfrm>
-            <a:off x="17373600" y="914400"/>
-            <a:ext cx="0" cy="4389120"/>
-          </a:xfrm>
-          <a:prstGeom prst="line">
-            <a:avLst/>
-          </a:prstGeom>
-          <a:ln w="19050">
-            <a:solidFill>
-              <a:srgbClr val="000000"/>
-            </a:solidFill>
-          </a:ln>
-        </p:spPr>
-        <p:style>
-          <a:lnRef idx="2">
-            <a:schemeClr val="accent1"/>
-          </a:lnRef>
-          <a:fillRef idx="0">
-            <a:schemeClr val="accent1"/>
-          </a:fillRef>
-          <a:effectRef idx="1">
-            <a:schemeClr val="accent1"/>
-          </a:effectRef>
-          <a:fontRef idx="minor">
-            <a:schemeClr val="tx1"/>
-          </a:fontRef>
-        </p:style>
-      </p:cxnSp>
-      <p:cxnSp>
-        <p:nvCxnSpPr>
-          <p:cNvPr id="47" name="Connector 46"/>
-          <p:cNvCxnSpPr/>
-          <p:nvPr/>
-        </p:nvCxnSpPr>
-        <p:spPr>
-          <a:xfrm flipH="1">
-            <a:off x="15910559" y="5303520"/>
-            <a:ext cx="1463041" cy="0"/>
-          </a:xfrm>
-          <a:prstGeom prst="line">
-            <a:avLst/>
-          </a:prstGeom>
-          <a:ln w="19050">
-            <a:solidFill>
-              <a:srgbClr val="000000"/>
-            </a:solidFill>
-          </a:ln>
-        </p:spPr>
-        <p:style>
-          <a:lnRef idx="2">
-            <a:schemeClr val="accent1"/>
-          </a:lnRef>
-          <a:fillRef idx="0">
-            <a:schemeClr val="accent1"/>
-          </a:fillRef>
-          <a:effectRef idx="1">
-            <a:schemeClr val="accent1"/>
-          </a:effectRef>
-          <a:fontRef idx="minor">
-            <a:schemeClr val="tx1"/>
-          </a:fontRef>
-        </p:style>
-      </p:cxnSp>
-      <p:cxnSp>
-        <p:nvCxnSpPr>
-          <p:cNvPr id="48" name="Connector 47"/>
-          <p:cNvCxnSpPr/>
-          <p:nvPr/>
-        </p:nvCxnSpPr>
-        <p:spPr>
-          <a:xfrm>
-            <a:off x="15910559" y="5303520"/>
-            <a:ext cx="0" cy="1371600"/>
+          <a:xfrm flipV="1">
+            <a:off x="3383280" y="5943600"/>
+            <a:ext cx="0" cy="3017520"/>
           </a:xfrm>
           <a:prstGeom prst="line">
             <a:avLst/>
@@ -4857,41 +4939,6 @@
               <a:srgbClr val="000000"/>
             </a:solidFill>
             <a:tailEnd type="triangle" w="med" len="med"/>
-          </a:ln>
-        </p:spPr>
-        <p:style>
-          <a:lnRef idx="2">
-            <a:schemeClr val="accent1"/>
-          </a:lnRef>
-          <a:fillRef idx="0">
-            <a:schemeClr val="accent1"/>
-          </a:fillRef>
-          <a:effectRef idx="1">
-            <a:schemeClr val="accent1"/>
-          </a:effectRef>
-          <a:fontRef idx="minor">
-            <a:schemeClr val="tx1"/>
-          </a:fontRef>
-        </p:style>
-      </p:cxnSp>
-      <p:cxnSp>
-        <p:nvCxnSpPr>
-          <p:cNvPr id="49" name="Connector 48"/>
-          <p:cNvCxnSpPr/>
-          <p:nvPr/>
-        </p:nvCxnSpPr>
-        <p:spPr>
-          <a:xfrm>
-            <a:off x="15636240" y="457200"/>
-            <a:ext cx="0" cy="365760"/>
-          </a:xfrm>
-          <a:prstGeom prst="line">
-            <a:avLst/>
-          </a:prstGeom>
-          <a:ln w="19050">
-            <a:solidFill>
-              <a:srgbClr val="000000"/>
-            </a:solidFill>
           </a:ln>
         </p:spPr>
         <p:style>
@@ -4912,13 +4959,15 @@
       <p:cxnSp>
         <p:nvCxnSpPr>
           <p:cNvPr id="50" name="Connector 49"/>
-          <p:cNvCxnSpPr/>
+          <p:cNvCxnSpPr>
+            <a:endCxn id="8" idx="2"/>
+          </p:cNvCxnSpPr>
           <p:nvPr/>
         </p:nvCxnSpPr>
         <p:spPr>
-          <a:xfrm>
-            <a:off x="15636240" y="822960"/>
-            <a:ext cx="0" cy="1920240"/>
+          <a:xfrm flipH="1" flipV="1">
+            <a:off x="6309360" y="5943600"/>
+            <a:ext cx="0" cy="3017520"/>
           </a:xfrm>
           <a:prstGeom prst="line">
             <a:avLst/>
@@ -4948,13 +4997,15 @@
       <p:cxnSp>
         <p:nvCxnSpPr>
           <p:cNvPr id="51" name="Connector 50"/>
-          <p:cNvCxnSpPr/>
+          <p:cNvCxnSpPr>
+            <a:endCxn id="10" idx="2"/>
+          </p:cNvCxnSpPr>
           <p:nvPr/>
         </p:nvCxnSpPr>
         <p:spPr>
-          <a:xfrm>
-            <a:off x="15636240" y="822960"/>
-            <a:ext cx="2011680" cy="0"/>
+          <a:xfrm flipV="1">
+            <a:off x="9235440" y="5943600"/>
+            <a:ext cx="0" cy="3017520"/>
           </a:xfrm>
           <a:prstGeom prst="line">
             <a:avLst/>
@@ -4963,6 +5014,7 @@
             <a:solidFill>
               <a:srgbClr val="000000"/>
             </a:solidFill>
+            <a:tailEnd type="triangle" w="med" len="med"/>
           </a:ln>
         </p:spPr>
         <p:style>
@@ -4983,13 +5035,15 @@
       <p:cxnSp>
         <p:nvCxnSpPr>
           <p:cNvPr id="52" name="Connector 51"/>
-          <p:cNvCxnSpPr/>
+          <p:cNvCxnSpPr>
+            <a:endCxn id="12" idx="2"/>
+          </p:cNvCxnSpPr>
           <p:nvPr/>
         </p:nvCxnSpPr>
         <p:spPr>
-          <a:xfrm>
-            <a:off x="17647920" y="822960"/>
-            <a:ext cx="0" cy="4846320"/>
+          <a:xfrm flipV="1">
+            <a:off x="12161520" y="5943600"/>
+            <a:ext cx="0" cy="3017520"/>
           </a:xfrm>
           <a:prstGeom prst="line">
             <a:avLst/>
@@ -4998,6 +5052,7 @@
             <a:solidFill>
               <a:srgbClr val="000000"/>
             </a:solidFill>
+            <a:tailEnd type="triangle" w="med" len="med"/>
           </a:ln>
         </p:spPr>
         <p:style>
@@ -5018,13 +5073,15 @@
       <p:cxnSp>
         <p:nvCxnSpPr>
           <p:cNvPr id="53" name="Connector 52"/>
-          <p:cNvCxnSpPr/>
+          <p:cNvCxnSpPr>
+            <a:endCxn id="14" idx="2"/>
+          </p:cNvCxnSpPr>
           <p:nvPr/>
         </p:nvCxnSpPr>
         <p:spPr>
-          <a:xfrm flipH="1">
-            <a:off x="16276320" y="5669280"/>
-            <a:ext cx="1371600" cy="0"/>
+          <a:xfrm flipV="1">
+            <a:off x="15087600" y="3931920"/>
+            <a:ext cx="0" cy="5029200"/>
           </a:xfrm>
           <a:prstGeom prst="line">
             <a:avLst/>
@@ -5033,6 +5090,7 @@
             <a:solidFill>
               <a:srgbClr val="000000"/>
             </a:solidFill>
+            <a:tailEnd type="triangle" w="med" len="med"/>
           </a:ln>
         </p:spPr>
         <p:style>
@@ -5053,13 +5111,15 @@
       <p:cxnSp>
         <p:nvCxnSpPr>
           <p:cNvPr id="54" name="Connector 53"/>
-          <p:cNvCxnSpPr/>
+          <p:cNvCxnSpPr>
+            <a:endCxn id="16" idx="2"/>
+          </p:cNvCxnSpPr>
           <p:nvPr/>
         </p:nvCxnSpPr>
         <p:spPr>
-          <a:xfrm>
-            <a:off x="16276320" y="5669280"/>
-            <a:ext cx="0" cy="1005840"/>
+          <a:xfrm flipV="1">
+            <a:off x="16916400" y="7863840"/>
+            <a:ext cx="0" cy="1097280"/>
           </a:xfrm>
           <a:prstGeom prst="line">
             <a:avLst/>
@@ -5069,146 +5129,6 @@
               <a:srgbClr val="000000"/>
             </a:solidFill>
             <a:tailEnd type="triangle" w="med" len="med"/>
-          </a:ln>
-        </p:spPr>
-        <p:style>
-          <a:lnRef idx="2">
-            <a:schemeClr val="accent1"/>
-          </a:lnRef>
-          <a:fillRef idx="0">
-            <a:schemeClr val="accent1"/>
-          </a:fillRef>
-          <a:effectRef idx="1">
-            <a:schemeClr val="accent1"/>
-          </a:effectRef>
-          <a:fontRef idx="minor">
-            <a:schemeClr val="tx1"/>
-          </a:fontRef>
-        </p:style>
-      </p:cxnSp>
-      <p:sp>
-        <p:nvSpPr>
-          <p:cNvPr id="55" name="TextBox 54"/>
-          <p:cNvSpPr txBox="1"/>
-          <p:nvPr/>
-        </p:nvSpPr>
-        <p:spPr>
-          <a:xfrm>
-            <a:off x="9235440" y="137160"/>
-            <a:ext cx="2103120" cy="548640"/>
-          </a:xfrm>
-          <a:prstGeom prst="rect">
-            <a:avLst/>
-          </a:prstGeom>
-          <a:noFill/>
-        </p:spPr>
-        <p:txBody>
-          <a:bodyPr wrap="square" anchor="t" lIns="12700" rIns="12700" tIns="12700" bIns="12700">
-            <a:spAutoFit/>
-          </a:bodyPr>
-          <a:lstStyle/>
-          <a:p>
-            <a:pPr algn="ctr"/>
-            <a:r>
-              <a:rPr sz="900" b="0">
-                <a:solidFill>
-                  <a:srgbClr val="000000"/>
-                </a:solidFill>
-                <a:latin typeface="Arial"/>
-              </a:rPr>
-              <a:t>C2 OPSEC / classification guidance</a:t>
-            </a:r>
-          </a:p>
-        </p:txBody>
-      </p:sp>
-      <p:sp>
-        <p:nvSpPr>
-          <p:cNvPr id="56" name="TextBox 55"/>
-          <p:cNvSpPr txBox="1"/>
-          <p:nvPr/>
-        </p:nvSpPr>
-        <p:spPr>
-          <a:xfrm>
-            <a:off x="12527280" y="137160"/>
-            <a:ext cx="2103120" cy="548640"/>
-          </a:xfrm>
-          <a:prstGeom prst="rect">
-            <a:avLst/>
-          </a:prstGeom>
-          <a:noFill/>
-        </p:spPr>
-        <p:txBody>
-          <a:bodyPr wrap="square" anchor="t" lIns="12700" rIns="12700" tIns="12700" bIns="12700">
-            <a:spAutoFit/>
-          </a:bodyPr>
-          <a:lstStyle/>
-          <a:p>
-            <a:pPr algn="ctr"/>
-            <a:r>
-              <a:rPr sz="900" b="0">
-                <a:solidFill>
-                  <a:srgbClr val="000000"/>
-                </a:solidFill>
-                <a:latin typeface="Arial"/>
-              </a:rPr>
-              <a:t>C3 Network availability and DDS QoS policies</a:t>
-            </a:r>
-          </a:p>
-        </p:txBody>
-      </p:sp>
-      <p:sp>
-        <p:nvSpPr>
-          <p:cNvPr id="57" name="TextBox 56"/>
-          <p:cNvSpPr txBox="1"/>
-          <p:nvPr/>
-        </p:nvSpPr>
-        <p:spPr>
-          <a:xfrm>
-            <a:off x="16002000" y="137160"/>
-            <a:ext cx="2103120" cy="548640"/>
-          </a:xfrm>
-          <a:prstGeom prst="rect">
-            <a:avLst/>
-          </a:prstGeom>
-          <a:noFill/>
-        </p:spPr>
-        <p:txBody>
-          <a:bodyPr wrap="square" anchor="t" lIns="12700" rIns="12700" tIns="12700" bIns="12700">
-            <a:spAutoFit/>
-          </a:bodyPr>
-          <a:lstStyle/>
-          <a:p>
-            <a:pPr algn="ctr"/>
-            <a:r>
-              <a:rPr sz="900" b="0">
-                <a:solidFill>
-                  <a:srgbClr val="000000"/>
-                </a:solidFill>
-                <a:latin typeface="Arial"/>
-              </a:rPr>
-              <a:t>C1 Mission objectives and operational constraints</a:t>
-            </a:r>
-          </a:p>
-        </p:txBody>
-      </p:sp>
-      <p:cxnSp>
-        <p:nvCxnSpPr>
-          <p:cNvPr id="58" name="Connector 57"/>
-          <p:cNvCxnSpPr/>
-          <p:nvPr/>
-        </p:nvCxnSpPr>
-        <p:spPr>
-          <a:xfrm>
-            <a:off x="13350240" y="4937760"/>
-            <a:ext cx="182880" cy="0"/>
-          </a:xfrm>
-          <a:prstGeom prst="line">
-            <a:avLst/>
-          </a:prstGeom>
-          <a:ln w="19050">
-            <a:solidFill>
-              <a:srgbClr val="000000"/>
-            </a:solidFill>
           </a:ln>
         </p:spPr>
         <p:style>
@@ -5228,22 +5148,25 @@
       </p:cxnSp>
       <p:cxnSp>
         <p:nvCxnSpPr>
-          <p:cNvPr id="59" name="Connector 58"/>
-          <p:cNvCxnSpPr/>
+          <p:cNvPr id="55" name="Connector 54"/>
+          <p:cNvCxnSpPr>
+            <a:endCxn id="8" idx="2"/>
+          </p:cNvCxnSpPr>
           <p:nvPr/>
         </p:nvCxnSpPr>
         <p:spPr>
-          <a:xfrm flipV="1">
-            <a:off x="13533120" y="1828800"/>
-            <a:ext cx="0" cy="3108960"/>
-          </a:xfrm>
-          <a:prstGeom prst="line">
+          <a:xfrm flipH="1" flipV="1">
+            <a:off x="6309360" y="5943600"/>
+            <a:ext cx="365760" cy="3017520"/>
+          </a:xfrm>
+          <a:prstGeom prst="bentConnector3">
             <a:avLst/>
           </a:prstGeom>
           <a:ln w="19050">
             <a:solidFill>
               <a:srgbClr val="000000"/>
             </a:solidFill>
+            <a:tailEnd type="triangle" w="med" len="med"/>
           </a:ln>
         </p:spPr>
         <p:style>
@@ -5263,16 +5186,18 @@
       </p:cxnSp>
       <p:cxnSp>
         <p:nvCxnSpPr>
-          <p:cNvPr id="60" name="Connector 59"/>
-          <p:cNvCxnSpPr/>
+          <p:cNvPr id="56" name="Connector 55"/>
+          <p:cNvCxnSpPr>
+            <a:endCxn id="10" idx="2"/>
+          </p:cNvCxnSpPr>
           <p:nvPr/>
         </p:nvCxnSpPr>
         <p:spPr>
-          <a:xfrm>
-            <a:off x="13533120" y="1828800"/>
-            <a:ext cx="4297680" cy="0"/>
-          </a:xfrm>
-          <a:prstGeom prst="line">
+          <a:xfrm flipH="1" flipV="1">
+            <a:off x="9235440" y="5943600"/>
+            <a:ext cx="365760" cy="3017520"/>
+          </a:xfrm>
+          <a:prstGeom prst="bentConnector3">
             <a:avLst/>
           </a:prstGeom>
           <a:ln w="19050">
@@ -5299,16 +5224,18 @@
       </p:cxnSp>
       <p:cxnSp>
         <p:nvCxnSpPr>
-          <p:cNvPr id="61" name="Connector 60"/>
-          <p:cNvCxnSpPr/>
+          <p:cNvPr id="57" name="Connector 56"/>
+          <p:cNvCxnSpPr>
+            <a:endCxn id="12" idx="2"/>
+          </p:cNvCxnSpPr>
           <p:nvPr/>
         </p:nvCxnSpPr>
         <p:spPr>
-          <a:xfrm>
-            <a:off x="16824960" y="3337560"/>
-            <a:ext cx="1005840" cy="0"/>
-          </a:xfrm>
-          <a:prstGeom prst="line">
+          <a:xfrm flipH="1" flipV="1">
+            <a:off x="12161520" y="5943600"/>
+            <a:ext cx="365760" cy="3017520"/>
+          </a:xfrm>
+          <a:prstGeom prst="bentConnector3">
             <a:avLst/>
           </a:prstGeom>
           <a:ln w="19050">
@@ -5335,16 +5262,18 @@
       </p:cxnSp>
       <p:cxnSp>
         <p:nvCxnSpPr>
-          <p:cNvPr id="62" name="Connector 61"/>
-          <p:cNvCxnSpPr/>
+          <p:cNvPr id="58" name="Connector 57"/>
+          <p:cNvCxnSpPr>
+            <a:endCxn id="16" idx="2"/>
+          </p:cNvCxnSpPr>
           <p:nvPr/>
         </p:nvCxnSpPr>
         <p:spPr>
-          <a:xfrm>
-            <a:off x="16824960" y="7269480"/>
-            <a:ext cx="1005840" cy="0"/>
-          </a:xfrm>
-          <a:prstGeom prst="line">
+          <a:xfrm flipH="1" flipV="1">
+            <a:off x="16916400" y="7863840"/>
+            <a:ext cx="365760" cy="1097280"/>
+          </a:xfrm>
+          <a:prstGeom prst="bentConnector3">
             <a:avLst/>
           </a:prstGeom>
           <a:ln w="19050">
@@ -5371,759 +5300,14 @@
       </p:cxnSp>
       <p:sp>
         <p:nvSpPr>
-          <p:cNvPr id="63" name="TextBox 62"/>
+          <p:cNvPr id="59" name="TextBox 58"/>
           <p:cNvSpPr txBox="1"/>
           <p:nvPr/>
         </p:nvSpPr>
         <p:spPr>
           <a:xfrm>
-            <a:off x="17967960" y="1627632"/>
-            <a:ext cx="2057400" cy="457200"/>
-          </a:xfrm>
-          <a:prstGeom prst="rect">
-            <a:avLst/>
-          </a:prstGeom>
-          <a:noFill/>
-        </p:spPr>
-        <p:txBody>
-          <a:bodyPr wrap="square" anchor="t" lIns="12700" rIns="12700" tIns="12700" bIns="12700">
-            <a:spAutoFit/>
-          </a:bodyPr>
-          <a:lstStyle/>
-          <a:p>
-            <a:pPr algn="l"/>
-            <a:r>
-              <a:rPr sz="900" b="0">
-                <a:solidFill>
-                  <a:srgbClr val="000000"/>
-                </a:solidFill>
-                <a:latin typeface="Arial"/>
-              </a:rPr>
-              <a:t>O1 Fused COWP State</a:t>
-            </a:r>
-          </a:p>
-        </p:txBody>
-      </p:sp>
-      <p:sp>
-        <p:nvSpPr>
-          <p:cNvPr id="64" name="TextBox 63"/>
-          <p:cNvSpPr txBox="1"/>
-          <p:nvPr/>
-        </p:nvSpPr>
-        <p:spPr>
-          <a:xfrm>
-            <a:off x="17967960" y="3127248"/>
-            <a:ext cx="2057400" cy="457200"/>
-          </a:xfrm>
-          <a:prstGeom prst="rect">
-            <a:avLst/>
-          </a:prstGeom>
-          <a:noFill/>
-        </p:spPr>
-        <p:txBody>
-          <a:bodyPr wrap="square" anchor="t" lIns="12700" rIns="12700" tIns="12700" bIns="12700">
-            <a:spAutoFit/>
-          </a:bodyPr>
-          <a:lstStyle/>
-          <a:p>
-            <a:pPr algn="l"/>
-            <a:r>
-              <a:rPr sz="900" b="0">
-                <a:solidFill>
-                  <a:srgbClr val="000000"/>
-                </a:solidFill>
-                <a:latin typeface="Arial"/>
-              </a:rPr>
-              <a:t>O3 Weather State Change Notifications</a:t>
-            </a:r>
-          </a:p>
-        </p:txBody>
-      </p:sp>
-      <p:sp>
-        <p:nvSpPr>
-          <p:cNvPr id="65" name="TextBox 64"/>
-          <p:cNvSpPr txBox="1"/>
-          <p:nvPr/>
-        </p:nvSpPr>
-        <p:spPr>
-          <a:xfrm>
-            <a:off x="17967960" y="7059168"/>
-            <a:ext cx="2057400" cy="457200"/>
-          </a:xfrm>
-          <a:prstGeom prst="rect">
-            <a:avLst/>
-          </a:prstGeom>
-          <a:noFill/>
-        </p:spPr>
-        <p:txBody>
-          <a:bodyPr wrap="square" anchor="t" lIns="12700" rIns="12700" tIns="12700" bIns="12700">
-            <a:spAutoFit/>
-          </a:bodyPr>
-          <a:lstStyle/>
-          <a:p>
-            <a:pPr algn="l"/>
-            <a:r>
-              <a:rPr sz="900" b="0">
-                <a:solidFill>
-                  <a:srgbClr val="000000"/>
-                </a:solidFill>
-                <a:latin typeface="Arial"/>
-              </a:rPr>
-              <a:t>O2 Mission-Tailored COWP Excerpts</a:t>
-            </a:r>
-          </a:p>
-        </p:txBody>
-      </p:sp>
-      <p:cxnSp>
-        <p:nvCxnSpPr>
-          <p:cNvPr id="66" name="Connector 65"/>
-          <p:cNvCxnSpPr/>
-          <p:nvPr/>
-        </p:nvCxnSpPr>
-        <p:spPr>
-          <a:xfrm flipV="1">
-            <a:off x="2743200" y="8412480"/>
-            <a:ext cx="0" cy="1417320"/>
-          </a:xfrm>
-          <a:prstGeom prst="line">
-            <a:avLst/>
-          </a:prstGeom>
-          <a:ln w="19050">
-            <a:solidFill>
-              <a:srgbClr val="000000"/>
-            </a:solidFill>
-          </a:ln>
-        </p:spPr>
-        <p:style>
-          <a:lnRef idx="2">
-            <a:schemeClr val="accent1"/>
-          </a:lnRef>
-          <a:fillRef idx="0">
-            <a:schemeClr val="accent1"/>
-          </a:fillRef>
-          <a:effectRef idx="1">
-            <a:schemeClr val="accent1"/>
-          </a:effectRef>
-          <a:fontRef idx="minor">
-            <a:schemeClr val="tx1"/>
-          </a:fontRef>
-        </p:style>
-      </p:cxnSp>
-      <p:cxnSp>
-        <p:nvCxnSpPr>
-          <p:cNvPr id="67" name="Connector 66"/>
-          <p:cNvCxnSpPr/>
-          <p:nvPr/>
-        </p:nvCxnSpPr>
-        <p:spPr>
-          <a:xfrm>
-            <a:off x="2560320" y="8412480"/>
-            <a:ext cx="13075920" cy="0"/>
-          </a:xfrm>
-          <a:prstGeom prst="line">
-            <a:avLst/>
-          </a:prstGeom>
-          <a:ln w="19050">
-            <a:solidFill>
-              <a:srgbClr val="000000"/>
-            </a:solidFill>
-          </a:ln>
-        </p:spPr>
-        <p:style>
-          <a:lnRef idx="2">
-            <a:schemeClr val="accent1"/>
-          </a:lnRef>
-          <a:fillRef idx="0">
-            <a:schemeClr val="accent1"/>
-          </a:fillRef>
-          <a:effectRef idx="1">
-            <a:schemeClr val="accent1"/>
-          </a:effectRef>
-          <a:fontRef idx="minor">
-            <a:schemeClr val="tx1"/>
-          </a:fontRef>
-        </p:style>
-      </p:cxnSp>
-      <p:cxnSp>
-        <p:nvCxnSpPr>
-          <p:cNvPr id="68" name="Connector 67"/>
-          <p:cNvCxnSpPr/>
-          <p:nvPr/>
-        </p:nvCxnSpPr>
-        <p:spPr>
-          <a:xfrm flipV="1">
-            <a:off x="2743200" y="5943600"/>
-            <a:ext cx="0" cy="2468880"/>
-          </a:xfrm>
-          <a:prstGeom prst="line">
-            <a:avLst/>
-          </a:prstGeom>
-          <a:ln w="19050">
-            <a:solidFill>
-              <a:srgbClr val="000000"/>
-            </a:solidFill>
-            <a:tailEnd type="triangle" w="med" len="med"/>
-          </a:ln>
-        </p:spPr>
-        <p:style>
-          <a:lnRef idx="2">
-            <a:schemeClr val="accent1"/>
-          </a:lnRef>
-          <a:fillRef idx="0">
-            <a:schemeClr val="accent1"/>
-          </a:fillRef>
-          <a:effectRef idx="1">
-            <a:schemeClr val="accent1"/>
-          </a:effectRef>
-          <a:fontRef idx="minor">
-            <a:schemeClr val="tx1"/>
-          </a:fontRef>
-        </p:style>
-      </p:cxnSp>
-      <p:cxnSp>
-        <p:nvCxnSpPr>
-          <p:cNvPr id="69" name="Connector 68"/>
-          <p:cNvCxnSpPr/>
-          <p:nvPr/>
-        </p:nvCxnSpPr>
-        <p:spPr>
-          <a:xfrm flipV="1">
-            <a:off x="5852160" y="5943600"/>
-            <a:ext cx="0" cy="2468880"/>
-          </a:xfrm>
-          <a:prstGeom prst="line">
-            <a:avLst/>
-          </a:prstGeom>
-          <a:ln w="19050">
-            <a:solidFill>
-              <a:srgbClr val="000000"/>
-            </a:solidFill>
-            <a:tailEnd type="triangle" w="med" len="med"/>
-          </a:ln>
-        </p:spPr>
-        <p:style>
-          <a:lnRef idx="2">
-            <a:schemeClr val="accent1"/>
-          </a:lnRef>
-          <a:fillRef idx="0">
-            <a:schemeClr val="accent1"/>
-          </a:fillRef>
-          <a:effectRef idx="1">
-            <a:schemeClr val="accent1"/>
-          </a:effectRef>
-          <a:fontRef idx="minor">
-            <a:schemeClr val="tx1"/>
-          </a:fontRef>
-        </p:style>
-      </p:cxnSp>
-      <p:cxnSp>
-        <p:nvCxnSpPr>
-          <p:cNvPr id="70" name="Connector 69"/>
-          <p:cNvCxnSpPr/>
-          <p:nvPr/>
-        </p:nvCxnSpPr>
-        <p:spPr>
-          <a:xfrm flipV="1">
-            <a:off x="8778240" y="5943600"/>
-            <a:ext cx="0" cy="2468880"/>
-          </a:xfrm>
-          <a:prstGeom prst="line">
-            <a:avLst/>
-          </a:prstGeom>
-          <a:ln w="19050">
-            <a:solidFill>
-              <a:srgbClr val="000000"/>
-            </a:solidFill>
-            <a:tailEnd type="triangle" w="med" len="med"/>
-          </a:ln>
-        </p:spPr>
-        <p:style>
-          <a:lnRef idx="2">
-            <a:schemeClr val="accent1"/>
-          </a:lnRef>
-          <a:fillRef idx="0">
-            <a:schemeClr val="accent1"/>
-          </a:fillRef>
-          <a:effectRef idx="1">
-            <a:schemeClr val="accent1"/>
-          </a:effectRef>
-          <a:fontRef idx="minor">
-            <a:schemeClr val="tx1"/>
-          </a:fontRef>
-        </p:style>
-      </p:cxnSp>
-      <p:cxnSp>
-        <p:nvCxnSpPr>
-          <p:cNvPr id="71" name="Connector 70"/>
-          <p:cNvCxnSpPr/>
-          <p:nvPr/>
-        </p:nvCxnSpPr>
-        <p:spPr>
-          <a:xfrm flipV="1">
-            <a:off x="11704320" y="5943600"/>
-            <a:ext cx="0" cy="2468880"/>
-          </a:xfrm>
-          <a:prstGeom prst="line">
-            <a:avLst/>
-          </a:prstGeom>
-          <a:ln w="19050">
-            <a:solidFill>
-              <a:srgbClr val="000000"/>
-            </a:solidFill>
-            <a:tailEnd type="triangle" w="med" len="med"/>
-          </a:ln>
-        </p:spPr>
-        <p:style>
-          <a:lnRef idx="2">
-            <a:schemeClr val="accent1"/>
-          </a:lnRef>
-          <a:fillRef idx="0">
-            <a:schemeClr val="accent1"/>
-          </a:fillRef>
-          <a:effectRef idx="1">
-            <a:schemeClr val="accent1"/>
-          </a:effectRef>
-          <a:fontRef idx="minor">
-            <a:schemeClr val="tx1"/>
-          </a:fontRef>
-        </p:style>
-      </p:cxnSp>
-      <p:cxnSp>
-        <p:nvCxnSpPr>
-          <p:cNvPr id="72" name="Connector 71"/>
-          <p:cNvCxnSpPr/>
-          <p:nvPr/>
-        </p:nvCxnSpPr>
-        <p:spPr>
-          <a:xfrm flipV="1">
-            <a:off x="15179040" y="7863840"/>
-            <a:ext cx="0" cy="548640"/>
-          </a:xfrm>
-          <a:prstGeom prst="line">
-            <a:avLst/>
-          </a:prstGeom>
-          <a:ln w="19050">
-            <a:solidFill>
-              <a:srgbClr val="000000"/>
-            </a:solidFill>
-            <a:tailEnd type="triangle" w="med" len="med"/>
-          </a:ln>
-        </p:spPr>
-        <p:style>
-          <a:lnRef idx="2">
-            <a:schemeClr val="accent1"/>
-          </a:lnRef>
-          <a:fillRef idx="0">
-            <a:schemeClr val="accent1"/>
-          </a:fillRef>
-          <a:effectRef idx="1">
-            <a:schemeClr val="accent1"/>
-          </a:effectRef>
-          <a:fontRef idx="minor">
-            <a:schemeClr val="tx1"/>
-          </a:fontRef>
-        </p:style>
-      </p:cxnSp>
-      <p:cxnSp>
-        <p:nvCxnSpPr>
-          <p:cNvPr id="73" name="Connector 72"/>
-          <p:cNvCxnSpPr/>
-          <p:nvPr/>
-        </p:nvCxnSpPr>
-        <p:spPr>
-          <a:xfrm flipV="1">
-            <a:off x="14081760" y="4480560"/>
-            <a:ext cx="0" cy="3931920"/>
-          </a:xfrm>
-          <a:prstGeom prst="line">
-            <a:avLst/>
-          </a:prstGeom>
-          <a:ln w="19050">
-            <a:solidFill>
-              <a:srgbClr val="000000"/>
-            </a:solidFill>
-          </a:ln>
-        </p:spPr>
-        <p:style>
-          <a:lnRef idx="2">
-            <a:schemeClr val="accent1"/>
-          </a:lnRef>
-          <a:fillRef idx="0">
-            <a:schemeClr val="accent1"/>
-          </a:fillRef>
-          <a:effectRef idx="1">
-            <a:schemeClr val="accent1"/>
-          </a:effectRef>
-          <a:fontRef idx="minor">
-            <a:schemeClr val="tx1"/>
-          </a:fontRef>
-        </p:style>
-      </p:cxnSp>
-      <p:cxnSp>
-        <p:nvCxnSpPr>
-          <p:cNvPr id="74" name="Connector 73"/>
-          <p:cNvCxnSpPr/>
-          <p:nvPr/>
-        </p:nvCxnSpPr>
-        <p:spPr>
-          <a:xfrm>
-            <a:off x="14081760" y="4480560"/>
-            <a:ext cx="1554480" cy="0"/>
-          </a:xfrm>
-          <a:prstGeom prst="line">
-            <a:avLst/>
-          </a:prstGeom>
-          <a:ln w="19050">
-            <a:solidFill>
-              <a:srgbClr val="000000"/>
-            </a:solidFill>
-          </a:ln>
-        </p:spPr>
-        <p:style>
-          <a:lnRef idx="2">
-            <a:schemeClr val="accent1"/>
-          </a:lnRef>
-          <a:fillRef idx="0">
-            <a:schemeClr val="accent1"/>
-          </a:fillRef>
-          <a:effectRef idx="1">
-            <a:schemeClr val="accent1"/>
-          </a:effectRef>
-          <a:fontRef idx="minor">
-            <a:schemeClr val="tx1"/>
-          </a:fontRef>
-        </p:style>
-      </p:cxnSp>
-      <p:cxnSp>
-        <p:nvCxnSpPr>
-          <p:cNvPr id="75" name="Connector 74"/>
-          <p:cNvCxnSpPr/>
-          <p:nvPr/>
-        </p:nvCxnSpPr>
-        <p:spPr>
-          <a:xfrm flipV="1">
-            <a:off x="15636240" y="3931920"/>
-            <a:ext cx="0" cy="548640"/>
-          </a:xfrm>
-          <a:prstGeom prst="line">
-            <a:avLst/>
-          </a:prstGeom>
-          <a:ln w="19050">
-            <a:solidFill>
-              <a:srgbClr val="000000"/>
-            </a:solidFill>
-            <a:tailEnd type="triangle" w="med" len="med"/>
-          </a:ln>
-        </p:spPr>
-        <p:style>
-          <a:lnRef idx="2">
-            <a:schemeClr val="accent1"/>
-          </a:lnRef>
-          <a:fillRef idx="0">
-            <a:schemeClr val="accent1"/>
-          </a:fillRef>
-          <a:effectRef idx="1">
-            <a:schemeClr val="accent1"/>
-          </a:effectRef>
-          <a:fontRef idx="minor">
-            <a:schemeClr val="tx1"/>
-          </a:fontRef>
-        </p:style>
-      </p:cxnSp>
-      <p:cxnSp>
-        <p:nvCxnSpPr>
-          <p:cNvPr id="76" name="Connector 75"/>
-          <p:cNvCxnSpPr/>
-          <p:nvPr/>
-        </p:nvCxnSpPr>
-        <p:spPr>
-          <a:xfrm flipV="1">
-            <a:off x="6400800" y="8778240"/>
-            <a:ext cx="0" cy="1051560"/>
-          </a:xfrm>
-          <a:prstGeom prst="line">
-            <a:avLst/>
-          </a:prstGeom>
-          <a:ln w="19050">
-            <a:solidFill>
-              <a:srgbClr val="000000"/>
-            </a:solidFill>
-          </a:ln>
-        </p:spPr>
-        <p:style>
-          <a:lnRef idx="2">
-            <a:schemeClr val="accent1"/>
-          </a:lnRef>
-          <a:fillRef idx="0">
-            <a:schemeClr val="accent1"/>
-          </a:fillRef>
-          <a:effectRef idx="1">
-            <a:schemeClr val="accent1"/>
-          </a:effectRef>
-          <a:fontRef idx="minor">
-            <a:schemeClr val="tx1"/>
-          </a:fontRef>
-        </p:style>
-      </p:cxnSp>
-      <p:cxnSp>
-        <p:nvCxnSpPr>
-          <p:cNvPr id="77" name="Connector 76"/>
-          <p:cNvCxnSpPr/>
-          <p:nvPr/>
-        </p:nvCxnSpPr>
-        <p:spPr>
-          <a:xfrm>
-            <a:off x="6217920" y="8778240"/>
-            <a:ext cx="2194560" cy="0"/>
-          </a:xfrm>
-          <a:prstGeom prst="line">
-            <a:avLst/>
-          </a:prstGeom>
-          <a:ln w="19050">
-            <a:solidFill>
-              <a:srgbClr val="000000"/>
-            </a:solidFill>
-          </a:ln>
-        </p:spPr>
-        <p:style>
-          <a:lnRef idx="2">
-            <a:schemeClr val="accent1"/>
-          </a:lnRef>
-          <a:fillRef idx="0">
-            <a:schemeClr val="accent1"/>
-          </a:fillRef>
-          <a:effectRef idx="1">
-            <a:schemeClr val="accent1"/>
-          </a:effectRef>
-          <a:fontRef idx="minor">
-            <a:schemeClr val="tx1"/>
-          </a:fontRef>
-        </p:style>
-      </p:cxnSp>
-      <p:cxnSp>
-        <p:nvCxnSpPr>
-          <p:cNvPr id="78" name="Connector 77"/>
-          <p:cNvCxnSpPr/>
-          <p:nvPr/>
-        </p:nvCxnSpPr>
-        <p:spPr>
-          <a:xfrm flipV="1">
-            <a:off x="6217920" y="5943600"/>
-            <a:ext cx="0" cy="2834640"/>
-          </a:xfrm>
-          <a:prstGeom prst="line">
-            <a:avLst/>
-          </a:prstGeom>
-          <a:ln w="19050">
-            <a:solidFill>
-              <a:srgbClr val="000000"/>
-            </a:solidFill>
-            <a:tailEnd type="triangle" w="med" len="med"/>
-          </a:ln>
-        </p:spPr>
-        <p:style>
-          <a:lnRef idx="2">
-            <a:schemeClr val="accent1"/>
-          </a:lnRef>
-          <a:fillRef idx="0">
-            <a:schemeClr val="accent1"/>
-          </a:fillRef>
-          <a:effectRef idx="1">
-            <a:schemeClr val="accent1"/>
-          </a:effectRef>
-          <a:fontRef idx="minor">
-            <a:schemeClr val="tx1"/>
-          </a:fontRef>
-        </p:style>
-      </p:cxnSp>
-      <p:cxnSp>
-        <p:nvCxnSpPr>
-          <p:cNvPr id="79" name="Connector 78"/>
-          <p:cNvCxnSpPr/>
-          <p:nvPr/>
-        </p:nvCxnSpPr>
-        <p:spPr>
-          <a:xfrm flipV="1">
-            <a:off x="8412480" y="5943600"/>
-            <a:ext cx="0" cy="2834640"/>
-          </a:xfrm>
-          <a:prstGeom prst="line">
-            <a:avLst/>
-          </a:prstGeom>
-          <a:ln w="19050">
-            <a:solidFill>
-              <a:srgbClr val="000000"/>
-            </a:solidFill>
-            <a:tailEnd type="triangle" w="med" len="med"/>
-          </a:ln>
-        </p:spPr>
-        <p:style>
-          <a:lnRef idx="2">
-            <a:schemeClr val="accent1"/>
-          </a:lnRef>
-          <a:fillRef idx="0">
-            <a:schemeClr val="accent1"/>
-          </a:fillRef>
-          <a:effectRef idx="1">
-            <a:schemeClr val="accent1"/>
-          </a:effectRef>
-          <a:fontRef idx="minor">
-            <a:schemeClr val="tx1"/>
-          </a:fontRef>
-        </p:style>
-      </p:cxnSp>
-      <p:cxnSp>
-        <p:nvCxnSpPr>
-          <p:cNvPr id="80" name="Connector 79"/>
-          <p:cNvCxnSpPr/>
-          <p:nvPr/>
-        </p:nvCxnSpPr>
-        <p:spPr>
-          <a:xfrm flipV="1">
-            <a:off x="12801600" y="9144000"/>
-            <a:ext cx="0" cy="685800"/>
-          </a:xfrm>
-          <a:prstGeom prst="line">
-            <a:avLst/>
-          </a:prstGeom>
-          <a:ln w="19050">
-            <a:solidFill>
-              <a:srgbClr val="000000"/>
-            </a:solidFill>
-          </a:ln>
-        </p:spPr>
-        <p:style>
-          <a:lnRef idx="2">
-            <a:schemeClr val="accent1"/>
-          </a:lnRef>
-          <a:fillRef idx="0">
-            <a:schemeClr val="accent1"/>
-          </a:fillRef>
-          <a:effectRef idx="1">
-            <a:schemeClr val="accent1"/>
-          </a:effectRef>
-          <a:fontRef idx="minor">
-            <a:schemeClr val="tx1"/>
-          </a:fontRef>
-        </p:style>
-      </p:cxnSp>
-      <p:cxnSp>
-        <p:nvCxnSpPr>
-          <p:cNvPr id="81" name="Connector 80"/>
-          <p:cNvCxnSpPr/>
-          <p:nvPr/>
-        </p:nvCxnSpPr>
-        <p:spPr>
-          <a:xfrm>
-            <a:off x="12435840" y="9144000"/>
-            <a:ext cx="3108960" cy="0"/>
-          </a:xfrm>
-          <a:prstGeom prst="line">
-            <a:avLst/>
-          </a:prstGeom>
-          <a:ln w="19050">
-            <a:solidFill>
-              <a:srgbClr val="000000"/>
-            </a:solidFill>
-          </a:ln>
-        </p:spPr>
-        <p:style>
-          <a:lnRef idx="2">
-            <a:schemeClr val="accent1"/>
-          </a:lnRef>
-          <a:fillRef idx="0">
-            <a:schemeClr val="accent1"/>
-          </a:fillRef>
-          <a:effectRef idx="1">
-            <a:schemeClr val="accent1"/>
-          </a:effectRef>
-          <a:fontRef idx="minor">
-            <a:schemeClr val="tx1"/>
-          </a:fontRef>
-        </p:style>
-      </p:cxnSp>
-      <p:cxnSp>
-        <p:nvCxnSpPr>
-          <p:cNvPr id="82" name="Connector 81"/>
-          <p:cNvCxnSpPr/>
-          <p:nvPr/>
-        </p:nvCxnSpPr>
-        <p:spPr>
-          <a:xfrm flipV="1">
-            <a:off x="12435840" y="5943600"/>
-            <a:ext cx="0" cy="3200400"/>
-          </a:xfrm>
-          <a:prstGeom prst="line">
-            <a:avLst/>
-          </a:prstGeom>
-          <a:ln w="19050">
-            <a:solidFill>
-              <a:srgbClr val="000000"/>
-            </a:solidFill>
-            <a:tailEnd type="triangle" w="med" len="med"/>
-          </a:ln>
-        </p:spPr>
-        <p:style>
-          <a:lnRef idx="2">
-            <a:schemeClr val="accent1"/>
-          </a:lnRef>
-          <a:fillRef idx="0">
-            <a:schemeClr val="accent1"/>
-          </a:fillRef>
-          <a:effectRef idx="1">
-            <a:schemeClr val="accent1"/>
-          </a:effectRef>
-          <a:fontRef idx="minor">
-            <a:schemeClr val="tx1"/>
-          </a:fontRef>
-        </p:style>
-      </p:cxnSp>
-      <p:cxnSp>
-        <p:nvCxnSpPr>
-          <p:cNvPr id="83" name="Connector 82"/>
-          <p:cNvCxnSpPr/>
-          <p:nvPr/>
-        </p:nvCxnSpPr>
-        <p:spPr>
-          <a:xfrm flipV="1">
-            <a:off x="15544800" y="7863840"/>
-            <a:ext cx="0" cy="1280160"/>
-          </a:xfrm>
-          <a:prstGeom prst="line">
-            <a:avLst/>
-          </a:prstGeom>
-          <a:ln w="19050">
-            <a:solidFill>
-              <a:srgbClr val="000000"/>
-            </a:solidFill>
-            <a:tailEnd type="triangle" w="med" len="med"/>
-          </a:ln>
-        </p:spPr>
-        <p:style>
-          <a:lnRef idx="2">
-            <a:schemeClr val="accent1"/>
-          </a:lnRef>
-          <a:fillRef idx="0">
-            <a:schemeClr val="accent1"/>
-          </a:fillRef>
-          <a:effectRef idx="1">
-            <a:schemeClr val="accent1"/>
-          </a:effectRef>
-          <a:fontRef idx="minor">
-            <a:schemeClr val="tx1"/>
-          </a:fontRef>
-        </p:style>
-      </p:cxnSp>
-      <p:sp>
-        <p:nvSpPr>
-          <p:cNvPr id="84" name="TextBox 83"/>
-          <p:cNvSpPr txBox="1"/>
-          <p:nvPr/>
-        </p:nvSpPr>
-        <p:spPr>
-          <a:xfrm>
-            <a:off x="1645920" y="9893808"/>
-            <a:ext cx="2743200" cy="292608"/>
+            <a:off x="1828800" y="9070848"/>
+            <a:ext cx="2926080" cy="292608"/>
           </a:xfrm>
           <a:prstGeom prst="rect">
             <a:avLst/>
@@ -6151,13 +5335,13 @@
       </p:sp>
       <p:sp>
         <p:nvSpPr>
-          <p:cNvPr id="85" name="TextBox 84"/>
+          <p:cNvPr id="60" name="TextBox 59"/>
           <p:cNvSpPr txBox="1"/>
           <p:nvPr/>
         </p:nvSpPr>
         <p:spPr>
           <a:xfrm>
-            <a:off x="5303520" y="9893808"/>
+            <a:off x="5486400" y="9070848"/>
             <a:ext cx="2743200" cy="292608"/>
           </a:xfrm>
           <a:prstGeom prst="rect">
@@ -6186,13 +5370,13 @@
       </p:sp>
       <p:sp>
         <p:nvSpPr>
-          <p:cNvPr id="86" name="TextBox 85"/>
+          <p:cNvPr id="61" name="TextBox 60"/>
           <p:cNvSpPr txBox="1"/>
           <p:nvPr/>
         </p:nvSpPr>
         <p:spPr>
           <a:xfrm>
-            <a:off x="11521440" y="9893808"/>
+            <a:off x="11521440" y="9070848"/>
             <a:ext cx="3108960" cy="292608"/>
           </a:xfrm>
           <a:prstGeom prst="rect">

</xml_diff>